<commit_message>
content: sync vault 2026-06-24T20:05Z
</commit_message>
<xml_diff>
--- a/content/98 資料/Strategy/2026-06-25_n8n-stack-ROI.pptx
+++ b/content/98 資料/Strategy/2026-06-25_n8n-stack-ROI.pptx
@@ -2014,7 +2014,7 @@
         <p:spPr>
           <a:xfrm>
             <a:off x="457200" y="1371600"/>
-            <a:ext cx="4069080" cy="1572768"/>
+            <a:ext cx="3886200" cy="1572768"/>
           </a:xfrm>
           <a:prstGeom prst="roundRect">
             <a:avLst>
@@ -2043,7 +2043,7 @@
         <p:spPr>
           <a:xfrm>
             <a:off x="713232" y="1554480"/>
-            <a:ext cx="3557016" cy="411480"/>
+            <a:ext cx="3374136" cy="411480"/>
           </a:xfrm>
           <a:prstGeom prst="rect">
             <a:avLst/>
@@ -2082,7 +2082,7 @@
         <p:spPr>
           <a:xfrm>
             <a:off x="713232" y="1993392"/>
-            <a:ext cx="3557016" cy="822960"/>
+            <a:ext cx="3374136" cy="822960"/>
           </a:xfrm>
           <a:prstGeom prst="rect">
             <a:avLst/>
@@ -2123,8 +2123,8 @@
         </p:nvSpPr>
         <p:spPr>
           <a:xfrm>
-            <a:off x="5074920" y="1371600"/>
-            <a:ext cx="4069080" cy="1572768"/>
+            <a:off x="4800600" y="1371600"/>
+            <a:ext cx="3886200" cy="1572768"/>
           </a:xfrm>
           <a:prstGeom prst="roundRect">
             <a:avLst>
@@ -2152,8 +2152,8 @@
         </p:nvSpPr>
         <p:spPr>
           <a:xfrm>
-            <a:off x="5330952" y="1554480"/>
-            <a:ext cx="3557016" cy="411480"/>
+            <a:off x="5056632" y="1554480"/>
+            <a:ext cx="3374136" cy="411480"/>
           </a:xfrm>
           <a:prstGeom prst="rect">
             <a:avLst/>
@@ -2191,8 +2191,8 @@
         </p:nvSpPr>
         <p:spPr>
           <a:xfrm>
-            <a:off x="5330952" y="1993392"/>
-            <a:ext cx="3557016" cy="822960"/>
+            <a:off x="5056632" y="1993392"/>
+            <a:ext cx="3374136" cy="822960"/>
           </a:xfrm>
           <a:prstGeom prst="rect">
             <a:avLst/>
@@ -2234,7 +2234,7 @@
         <p:spPr>
           <a:xfrm>
             <a:off x="457200" y="3236976"/>
-            <a:ext cx="4069080" cy="1572768"/>
+            <a:ext cx="3886200" cy="1572768"/>
           </a:xfrm>
           <a:prstGeom prst="roundRect">
             <a:avLst>
@@ -2263,7 +2263,7 @@
         <p:spPr>
           <a:xfrm>
             <a:off x="713232" y="3419856"/>
-            <a:ext cx="3557016" cy="411480"/>
+            <a:ext cx="3374136" cy="411480"/>
           </a:xfrm>
           <a:prstGeom prst="rect">
             <a:avLst/>
@@ -2302,7 +2302,7 @@
         <p:spPr>
           <a:xfrm>
             <a:off x="713232" y="3858768"/>
-            <a:ext cx="3557016" cy="822960"/>
+            <a:ext cx="3374136" cy="822960"/>
           </a:xfrm>
           <a:prstGeom prst="rect">
             <a:avLst/>
@@ -2343,8 +2343,8 @@
         </p:nvSpPr>
         <p:spPr>
           <a:xfrm>
-            <a:off x="5074920" y="3236976"/>
-            <a:ext cx="4069080" cy="1572768"/>
+            <a:off x="4800600" y="3236976"/>
+            <a:ext cx="3886200" cy="1572768"/>
           </a:xfrm>
           <a:prstGeom prst="roundRect">
             <a:avLst>
@@ -2372,8 +2372,8 @@
         </p:nvSpPr>
         <p:spPr>
           <a:xfrm>
-            <a:off x="5330952" y="3419856"/>
-            <a:ext cx="3557016" cy="411480"/>
+            <a:off x="5056632" y="3419856"/>
+            <a:ext cx="3374136" cy="411480"/>
           </a:xfrm>
           <a:prstGeom prst="rect">
             <a:avLst/>
@@ -2411,8 +2411,8 @@
         </p:nvSpPr>
         <p:spPr>
           <a:xfrm>
-            <a:off x="5330952" y="3858768"/>
-            <a:ext cx="3557016" cy="822960"/>
+            <a:off x="5056632" y="3858768"/>
+            <a:ext cx="3374136" cy="822960"/>
           </a:xfrm>
           <a:prstGeom prst="rect">
             <a:avLst/>
@@ -5281,12 +5281,12 @@
         </p:nvSpPr>
         <p:spPr>
           <a:xfrm>
-            <a:off x="457200" y="1325880"/>
-            <a:ext cx="8229600" cy="749808"/>
+            <a:off x="457200" y="1298448"/>
+            <a:ext cx="8229600" cy="731520"/>
           </a:xfrm>
           <a:prstGeom prst="roundRect">
             <a:avLst>
-              <a:gd name="adj" fmla="val 7317"/>
+              <a:gd name="adj" fmla="val 7500"/>
             </a:avLst>
           </a:prstGeom>
           <a:solidFill>
@@ -5303,7 +5303,7 @@
         </p:nvSpPr>
         <p:spPr>
           <a:xfrm>
-            <a:off x="658368" y="1517904"/>
+            <a:off x="658368" y="1490472"/>
             <a:ext cx="365760" cy="365760"/>
           </a:xfrm>
           <a:prstGeom prst="ellipse">
@@ -5323,7 +5323,7 @@
         </p:nvSpPr>
         <p:spPr>
           <a:xfrm>
-            <a:off x="658368" y="1517904"/>
+            <a:off x="658368" y="1490472"/>
             <a:ext cx="365760" cy="365760"/>
           </a:xfrm>
           <a:prstGeom prst="rect">
@@ -5362,8 +5362,8 @@
         </p:nvSpPr>
         <p:spPr>
           <a:xfrm>
-            <a:off x="1234440" y="1325880"/>
-            <a:ext cx="7315200" cy="749808"/>
+            <a:off x="1234440" y="1298448"/>
+            <a:ext cx="7315200" cy="731520"/>
           </a:xfrm>
           <a:prstGeom prst="rect">
             <a:avLst/>
@@ -5421,12 +5421,12 @@
         </p:nvSpPr>
         <p:spPr>
           <a:xfrm>
-            <a:off x="457200" y="2185416"/>
-            <a:ext cx="8229600" cy="749808"/>
+            <a:off x="457200" y="2121408"/>
+            <a:ext cx="8229600" cy="731520"/>
           </a:xfrm>
           <a:prstGeom prst="roundRect">
             <a:avLst>
-              <a:gd name="adj" fmla="val 7317"/>
+              <a:gd name="adj" fmla="val 7500"/>
             </a:avLst>
           </a:prstGeom>
           <a:solidFill>
@@ -5443,7 +5443,7 @@
         </p:nvSpPr>
         <p:spPr>
           <a:xfrm>
-            <a:off x="658368" y="2377440"/>
+            <a:off x="658368" y="2313432"/>
             <a:ext cx="365760" cy="365760"/>
           </a:xfrm>
           <a:prstGeom prst="ellipse">
@@ -5463,7 +5463,7 @@
         </p:nvSpPr>
         <p:spPr>
           <a:xfrm>
-            <a:off x="658368" y="2377440"/>
+            <a:off x="658368" y="2313432"/>
             <a:ext cx="365760" cy="365760"/>
           </a:xfrm>
           <a:prstGeom prst="rect">
@@ -5502,8 +5502,8 @@
         </p:nvSpPr>
         <p:spPr>
           <a:xfrm>
-            <a:off x="1234440" y="2185416"/>
-            <a:ext cx="7315200" cy="749808"/>
+            <a:off x="1234440" y="2121408"/>
+            <a:ext cx="7315200" cy="731520"/>
           </a:xfrm>
           <a:prstGeom prst="rect">
             <a:avLst/>
@@ -5561,12 +5561,12 @@
         </p:nvSpPr>
         <p:spPr>
           <a:xfrm>
-            <a:off x="457200" y="3044952"/>
-            <a:ext cx="8229600" cy="749808"/>
+            <a:off x="457200" y="2944368"/>
+            <a:ext cx="8229600" cy="731520"/>
           </a:xfrm>
           <a:prstGeom prst="roundRect">
             <a:avLst>
-              <a:gd name="adj" fmla="val 7317"/>
+              <a:gd name="adj" fmla="val 7500"/>
             </a:avLst>
           </a:prstGeom>
           <a:solidFill>
@@ -5583,7 +5583,7 @@
         </p:nvSpPr>
         <p:spPr>
           <a:xfrm>
-            <a:off x="658368" y="3236976"/>
+            <a:off x="658368" y="3136392"/>
             <a:ext cx="365760" cy="365760"/>
           </a:xfrm>
           <a:prstGeom prst="ellipse">
@@ -5603,7 +5603,7 @@
         </p:nvSpPr>
         <p:spPr>
           <a:xfrm>
-            <a:off x="658368" y="3236976"/>
+            <a:off x="658368" y="3136392"/>
             <a:ext cx="365760" cy="365760"/>
           </a:xfrm>
           <a:prstGeom prst="rect">
@@ -5642,8 +5642,8 @@
         </p:nvSpPr>
         <p:spPr>
           <a:xfrm>
-            <a:off x="1234440" y="3044952"/>
-            <a:ext cx="7315200" cy="749808"/>
+            <a:off x="1234440" y="2944368"/>
+            <a:ext cx="7315200" cy="731520"/>
           </a:xfrm>
           <a:prstGeom prst="rect">
             <a:avLst/>
@@ -5701,12 +5701,12 @@
         </p:nvSpPr>
         <p:spPr>
           <a:xfrm>
-            <a:off x="457200" y="3904488"/>
-            <a:ext cx="8229600" cy="749808"/>
+            <a:off x="457200" y="3767328"/>
+            <a:ext cx="8229600" cy="731520"/>
           </a:xfrm>
           <a:prstGeom prst="roundRect">
             <a:avLst>
-              <a:gd name="adj" fmla="val 7317"/>
+              <a:gd name="adj" fmla="val 7500"/>
             </a:avLst>
           </a:prstGeom>
           <a:solidFill>
@@ -5723,7 +5723,7 @@
         </p:nvSpPr>
         <p:spPr>
           <a:xfrm>
-            <a:off x="658368" y="4096512"/>
+            <a:off x="658368" y="3959352"/>
             <a:ext cx="365760" cy="365760"/>
           </a:xfrm>
           <a:prstGeom prst="ellipse">
@@ -5743,7 +5743,7 @@
         </p:nvSpPr>
         <p:spPr>
           <a:xfrm>
-            <a:off x="658368" y="4096512"/>
+            <a:off x="658368" y="3959352"/>
             <a:ext cx="365760" cy="365760"/>
           </a:xfrm>
           <a:prstGeom prst="rect">
@@ -5782,8 +5782,8 @@
         </p:nvSpPr>
         <p:spPr>
           <a:xfrm>
-            <a:off x="1234440" y="3904488"/>
-            <a:ext cx="7315200" cy="749808"/>
+            <a:off x="1234440" y="3767328"/>
+            <a:ext cx="7315200" cy="731520"/>
           </a:xfrm>
           <a:prstGeom prst="rect">
             <a:avLst/>

</xml_diff>